<commit_message>
Remove the tests slide from the final presentation
</commit_message>
<xml_diff>
--- a/docs/FitMeet-presentation.pptx
+++ b/docs/FitMeet-presentation.pptx
@@ -15,7 +15,6 @@
     <p:sldId id="263" r:id="rId15"/>
     <p:sldId id="264" r:id="rId16"/>
     <p:sldId id="265" r:id="rId17"/>
-    <p:sldId id="266" r:id="rId18"/>
   </p:sldIdLst>
   <p:sldSz cx="12191695" cy="6858000" type="screen4x3"/>
   <p:notesSz cx="6858000" cy="9144000"/>
@@ -588,101 +587,19 @@
           <a:lstStyle/>
           <a:p>
             <a:r>
-              <a:t>On bascule sur l'application.</a:t>
+              <a:t>Questions probables.</a:t>
             </a:r>
           </a:p>
           <a:p/>
           <a:p>
             <a:r>
-              <a:t>Je crée une séance de badminton à Yverdon, elle apparaît dans la liste et sur la carte, puis un deuxième compte la rejoint et la place disparaît.</a:t>
+              <a:t>Pourquoi Kotlin Multiplatform plutôt que React Native ou Flutter : rendu natif, et l'équipe connaissait déjà Kotlin.</a:t>
             </a:r>
           </a:p>
           <a:p/>
           <a:p>
             <a:r>
-              <a:t>Repli si le réseau lâche : les captures de la diapositive « Le produit ».</a:t>
-            </a:r>
-          </a:p>
-        </p:txBody>
-      </p:sp>
-      <p:sp>
-        <p:nvSpPr>
-          <p:cNvPr id="4" name="Slide Number Placeholder 3"/>
-          <p:cNvSpPr>
-            <a:spLocks noGrp="1"/>
-          </p:cNvSpPr>
-          <p:nvPr>
-            <p:ph type="sldNum" idx="5" sz="quarter"/>
-          </p:nvPr>
-        </p:nvSpPr>
-        <p:spPr/>
-      </p:sp>
-    </p:spTree>
-  </p:cSld>
-  <p:clrMapOvr>
-    <a:masterClrMapping/>
-  </p:clrMapOvr>
-</p:notes>
-</file>
-
-<file path=ppt/notesSlides/notesSlide11.xml><?xml version="1.0" encoding="utf-8"?>
-<p:notes xmlns:a="http://schemas.openxmlformats.org/drawingml/2006/main" xmlns:p="http://schemas.openxmlformats.org/presentationml/2006/main" xmlns:r="http://schemas.openxmlformats.org/officeDocument/2006/relationships">
-  <p:cSld>
-    <p:spTree>
-      <p:nvGrpSpPr>
-        <p:cNvPr id="1" name=""/>
-        <p:cNvGrpSpPr/>
-        <p:nvPr/>
-      </p:nvGrpSpPr>
-      <p:grpSpPr>
-        <a:xfrm>
-          <a:off x="0" y="0"/>
-          <a:ext cx="0" cy="0"/>
-          <a:chOff x="0" y="0"/>
-          <a:chExt cx="0" cy="0"/>
-        </a:xfrm>
-      </p:grpSpPr>
-      <p:sp>
-        <p:nvSpPr>
-          <p:cNvPr id="2" name="Slide Image Placeholder 1"/>
-          <p:cNvSpPr>
-            <a:spLocks noGrp="1"/>
-          </p:cNvSpPr>
-          <p:nvPr>
-            <p:ph type="sldImg" idx="2"/>
-          </p:nvPr>
-        </p:nvSpPr>
-        <p:spPr/>
-      </p:sp>
-      <p:sp>
-        <p:nvSpPr>
-          <p:cNvPr id="3" name="Notes Placeholder 2"/>
-          <p:cNvSpPr>
-            <a:spLocks noGrp="1"/>
-          </p:cNvSpPr>
-          <p:nvPr>
-            <p:ph type="body" idx="3" sz="quarter"/>
-          </p:nvPr>
-        </p:nvSpPr>
-        <p:spPr/>
-        <p:txBody>
-          <a:bodyPr/>
-          <a:lstStyle/>
-          <a:p>
-            <a:r>
-              <a:t>Questions probables.</a:t>
-            </a:r>
-          </a:p>
-          <a:p/>
-          <a:p>
-            <a:r>
-              <a:t>Pourquoi Kotlin Multiplatform plutôt que React Native ou Flutter : rendu natif, et l'équipe connaissait déjà Kotlin.</a:t>
-            </a:r>
-          </a:p>
-          <a:p/>
-          <a:p>
-            <a:r>
-              <a:t>Pourquoi si peu de tests : arbitrage assumé, expliqué à la diapositive Tests.</a:t>
+              <a:t>Sur les tests : le pipeline lance la tâche de tests du module partagé à chaque pull request. La couverture est volontairement faible, nous avons priorisé les fonctionnalités sur trois semaines. C'est Pierre qui a porté cette partie.</a:t>
             </a:r>
           </a:p>
           <a:p/>
@@ -1332,19 +1249,19 @@
           <a:lstStyle/>
           <a:p>
             <a:r>
-              <a:t>Huit tests unitaires partagés, sur la logique qui se casse sans se voir : les filtres et le tri par distance. Exemple réel : le tri remontait les activités sans coordonnées comme les plus proches. Un test l'a détecté.</a:t>
+              <a:t>On bascule sur l'application.</a:t>
             </a:r>
           </a:p>
           <a:p/>
           <a:p>
             <a:r>
-              <a:t>Ce que nous n'avons pas fait : les notifications, une couverture mince, et un iOS compilé à chaque changement mais peu utilisé sur un appareil réel.</a:t>
+              <a:t>Je crée une séance de badminton à Yverdon, elle apparaît dans la liste et sur la carte, puis un deuxième compte la rejoint et la place disparaît.</a:t>
             </a:r>
           </a:p>
           <a:p/>
           <a:p>
             <a:r>
-              <a:t>En bas, l'effort sur trois semaines.</a:t>
+              <a:t>Repli si le réseau lâche : les captures de la diapositive « Le produit ».</a:t>
             </a:r>
           </a:p>
         </p:txBody>
@@ -4632,7 +4549,7 @@
     <p:bg>
       <p:bgPr>
         <a:solidFill>
-          <a:srgbClr val="2E6B4E"/>
+          <a:srgbClr val="0B2545"/>
         </a:solidFill>
         <a:effectLst/>
       </p:bgPr>
@@ -4646,14 +4563,58 @@
       <p:grpSpPr/>
       <p:sp>
         <p:nvSpPr>
-          <p:cNvPr id="2" name="TextBox 1"/>
-          <p:cNvSpPr txBox="1"/>
-          <p:nvPr/>
-        </p:nvSpPr>
-        <p:spPr>
-          <a:xfrm>
-            <a:off x="868680" y="2286000"/>
-            <a:ext cx="5852160" cy="320040"/>
+          <p:cNvPr id="2" name="Rectangle 1"/>
+          <p:cNvSpPr/>
+          <p:nvPr/>
+        </p:nvSpPr>
+        <p:spPr>
+          <a:xfrm>
+            <a:off x="0" y="0"/>
+            <a:ext cx="146304" cy="6858000"/>
+          </a:xfrm>
+          <a:prstGeom prst="rect">
+            <a:avLst/>
+          </a:prstGeom>
+          <a:solidFill>
+            <a:srgbClr val="3E8E68"/>
+          </a:solidFill>
+          <a:ln>
+            <a:noFill/>
+          </a:ln>
+          <a:effectLst/>
+        </p:spPr>
+        <p:style>
+          <a:lnRef idx="1">
+            <a:schemeClr val="accent1"/>
+          </a:lnRef>
+          <a:fillRef idx="3">
+            <a:schemeClr val="accent1"/>
+          </a:fillRef>
+          <a:effectRef idx="2">
+            <a:schemeClr val="accent1"/>
+          </a:effectRef>
+          <a:fontRef idx="minor">
+            <a:schemeClr val="lt1"/>
+          </a:fontRef>
+        </p:style>
+        <p:txBody>
+          <a:bodyPr rtlCol="0" anchor="ctr" wrap="square"/>
+          <a:lstStyle/>
+          <a:p>
+            <a:pPr algn="ctr"/>
+          </a:p>
+        </p:txBody>
+      </p:sp>
+      <p:sp>
+        <p:nvSpPr>
+          <p:cNvPr id="3" name="TextBox 2"/>
+          <p:cNvSpPr txBox="1"/>
+          <p:nvPr/>
+        </p:nvSpPr>
+        <p:spPr>
+          <a:xfrm>
+            <a:off x="868680" y="2148840"/>
+            <a:ext cx="8229600" cy="320040"/>
           </a:xfrm>
           <a:prstGeom prst="rect">
             <a:avLst/>
@@ -4678,26 +4639,26 @@
               </a:spcAft>
             </a:pPr>
             <a:r>
-              <a:rPr sz="1100" b="1" i="0" spc="190">
+              <a:rPr sz="1200" b="1" i="0" spc="220">
                 <a:solidFill>
                   <a:srgbClr val="8FC7AA"/>
                 </a:solidFill>
                 <a:latin typeface="Inter"/>
               </a:rPr>
-              <a:t>DÉMONSTRATION</a:t>
-            </a:r>
-          </a:p>
-        </p:txBody>
-      </p:sp>
-      <p:sp>
-        <p:nvSpPr>
-          <p:cNvPr id="3" name="TextBox 2"/>
-          <p:cNvSpPr txBox="1"/>
-          <p:nvPr/>
-        </p:nvSpPr>
-        <p:spPr>
-          <a:xfrm>
-            <a:off x="868680" y="2743200"/>
+              <a:t>MERCI</a:t>
+            </a:r>
+          </a:p>
+        </p:txBody>
+      </p:sp>
+      <p:sp>
+        <p:nvSpPr>
+          <p:cNvPr id="4" name="TextBox 3"/>
+          <p:cNvSpPr txBox="1"/>
+          <p:nvPr/>
+        </p:nvSpPr>
+        <p:spPr>
+          <a:xfrm>
+            <a:off x="868680" y="2578608"/>
             <a:ext cx="10454335" cy="914400"/>
           </a:xfrm>
           <a:prstGeom prst="rect">
@@ -4723,34 +4684,34 @@
               </a:spcAft>
             </a:pPr>
             <a:r>
-              <a:rPr sz="4400" b="1" i="0">
+              <a:rPr sz="4600" b="1" i="0">
                 <a:solidFill>
                   <a:srgbClr val="FFFFFF"/>
                 </a:solidFill>
                 <a:latin typeface="Fraunces"/>
               </a:rPr>
-              <a:t>L'application</a:t>
+              <a:t>Des questions ?</a:t>
             </a:r>
           </a:p>
         </p:txBody>
       </p:sp>
       <p:cxnSp>
         <p:nvCxnSpPr>
-          <p:cNvPr id="4" name="Connector 3"/>
+          <p:cNvPr id="5" name="Connector 4"/>
           <p:cNvCxnSpPr/>
           <p:nvPr/>
         </p:nvCxnSpPr>
         <p:spPr>
           <a:xfrm>
-            <a:off x="868680" y="3931920"/>
-            <a:ext cx="2377440" cy="0"/>
+            <a:off x="868680" y="3794760"/>
+            <a:ext cx="2926080" cy="0"/>
           </a:xfrm>
           <a:prstGeom prst="line">
             <a:avLst/>
           </a:prstGeom>
           <a:ln w="19050">
             <a:solidFill>
-              <a:srgbClr val="8FC7AA"/>
+              <a:srgbClr val="3E8E68"/>
             </a:solidFill>
           </a:ln>
         </p:spPr>
@@ -4771,14 +4732,14 @@
       </p:cxnSp>
       <p:sp>
         <p:nvSpPr>
-          <p:cNvPr id="5" name="TextBox 4"/>
-          <p:cNvSpPr txBox="1"/>
-          <p:nvPr/>
-        </p:nvSpPr>
-        <p:spPr>
-          <a:xfrm>
-            <a:off x="868680" y="4206240"/>
-            <a:ext cx="7132320" cy="1645920"/>
+          <p:cNvPr id="6" name="TextBox 5"/>
+          <p:cNvSpPr txBox="1"/>
+          <p:nvPr/>
+        </p:nvSpPr>
+        <p:spPr>
+          <a:xfrm>
+            <a:off x="868680" y="3977639"/>
+            <a:ext cx="5120640" cy="1371600"/>
           </a:xfrm>
           <a:prstGeom prst="rect">
             <a:avLst/>
@@ -4793,94 +4754,94 @@
           <a:p>
             <a:pPr algn="l">
               <a:lnSpc>
-                <a:spcPct val="140000"/>
-              </a:lnSpc>
-              <a:spcBef>
-                <a:spcPts val="0"/>
-              </a:spcBef>
-              <a:spcAft>
-                <a:spcPts val="900"/>
-              </a:spcAft>
-            </a:pPr>
-            <a:r>
-              <a:rPr sz="1550" b="0" i="0">
+                <a:spcPct val="125000"/>
+              </a:lnSpc>
+              <a:spcBef>
+                <a:spcPts val="0"/>
+              </a:spcBef>
+              <a:spcAft>
+                <a:spcPts val="700"/>
+              </a:spcAft>
+            </a:pPr>
+            <a:r>
+              <a:rPr sz="1450" b="0" i="0">
                 <a:solidFill>
                   <a:srgbClr val="FFFFFF"/>
                 </a:solidFill>
                 <a:latin typeface="Inter"/>
               </a:rPr>
-              <a:t>—   Je crée une séance de badminton à Yverdon.</a:t>
+              <a:t>github.com/mircoprofico/FitMeet</a:t>
             </a:r>
           </a:p>
           <a:p>
             <a:pPr algn="l">
               <a:lnSpc>
-                <a:spcPct val="140000"/>
-              </a:lnSpc>
-              <a:spcBef>
-                <a:spcPts val="0"/>
-              </a:spcBef>
-              <a:spcAft>
-                <a:spcPts val="900"/>
-              </a:spcAft>
-            </a:pPr>
-            <a:r>
-              <a:rPr sz="1550" b="0" i="0">
-                <a:solidFill>
-                  <a:srgbClr val="FFFFFF"/>
+                <a:spcPct val="125000"/>
+              </a:lnSpc>
+              <a:spcBef>
+                <a:spcPts val="0"/>
+              </a:spcBef>
+              <a:spcAft>
+                <a:spcPts val="700"/>
+              </a:spcAft>
+            </a:pPr>
+            <a:r>
+              <a:rPr sz="1450" b="0" i="0">
+                <a:solidFill>
+                  <a:srgbClr val="8FC7AA"/>
                 </a:solidFill>
                 <a:latin typeface="Inter"/>
               </a:rPr>
-              <a:t>—   Elle apparaît dans la liste et sur la carte.</a:t>
-            </a:r>
-          </a:p>
+              <a:t>mircoprofico.github.io/FitMeet</a:t>
+            </a:r>
+          </a:p>
+        </p:txBody>
+      </p:sp>
+      <p:sp>
+        <p:nvSpPr>
+          <p:cNvPr id="7" name="TextBox 6"/>
+          <p:cNvSpPr txBox="1"/>
+          <p:nvPr/>
+        </p:nvSpPr>
+        <p:spPr>
+          <a:xfrm>
+            <a:off x="6766560" y="3977639"/>
+            <a:ext cx="4480560" cy="1463040"/>
+          </a:xfrm>
+          <a:prstGeom prst="rect">
+            <a:avLst/>
+          </a:prstGeom>
+          <a:noFill/>
+        </p:spPr>
+        <p:txBody>
+          <a:bodyPr wrap="square" anchor="t" lIns="0" rIns="0" tIns="0" bIns="0">
+            <a:spAutoFit/>
+          </a:bodyPr>
+          <a:lstStyle/>
           <a:p>
             <a:pPr algn="l">
               <a:lnSpc>
-                <a:spcPct val="140000"/>
-              </a:lnSpc>
-              <a:spcBef>
-                <a:spcPts val="0"/>
-              </a:spcBef>
-              <a:spcAft>
-                <a:spcPts val="900"/>
-              </a:spcAft>
-            </a:pPr>
-            <a:r>
-              <a:rPr sz="1550" b="0" i="0">
-                <a:solidFill>
-                  <a:srgbClr val="FFFFFF"/>
+                <a:spcPct val="125000"/>
+              </a:lnSpc>
+              <a:spcBef>
+                <a:spcPts val="0"/>
+              </a:spcBef>
+              <a:spcAft>
+                <a:spcPts val="600"/>
+              </a:spcAft>
+            </a:pPr>
+            <a:r>
+              <a:rPr sz="1300" b="0" i="0">
+                <a:solidFill>
+                  <a:srgbClr val="8DA0B5"/>
                 </a:solidFill>
                 <a:latin typeface="Inter"/>
               </a:rPr>
-              <a:t>—   Un deuxième compte la rejoint : la place disparaît.</a:t>
-            </a:r>
-          </a:p>
-        </p:txBody>
-      </p:sp>
-      <p:sp>
-        <p:nvSpPr>
-          <p:cNvPr id="6" name="TextBox 5"/>
-          <p:cNvSpPr txBox="1"/>
-          <p:nvPr/>
-        </p:nvSpPr>
-        <p:spPr>
-          <a:xfrm>
-            <a:off x="10774375" y="6309360"/>
-            <a:ext cx="548640" cy="237744"/>
-          </a:xfrm>
-          <a:prstGeom prst="rect">
-            <a:avLst/>
-          </a:prstGeom>
-          <a:noFill/>
-        </p:spPr>
-        <p:txBody>
-          <a:bodyPr wrap="square" anchor="t" lIns="0" rIns="0" tIns="0" bIns="0">
-            <a:spAutoFit/>
-          </a:bodyPr>
-          <a:lstStyle/>
-          <a:p>
-            <a:pPr algn="r">
+              <a:t>Mirco Profico   ·   Antoine Aubry</a:t>
+            </a:r>
+          </a:p>
+          <a:p>
+            <a:pPr algn="l">
               <a:lnSpc>
                 <a:spcPct val="125000"/>
               </a:lnSpc>
@@ -4888,198 +4849,60 @@
                 <a:spcPts val="0"/>
               </a:spcBef>
               <a:spcAft>
-                <a:spcPts val="0"/>
-              </a:spcAft>
-            </a:pPr>
-            <a:r>
-              <a:rPr sz="950" b="0" i="0">
+                <a:spcPts val="600"/>
+              </a:spcAft>
+            </a:pPr>
+            <a:r>
+              <a:rPr sz="1300" b="0" i="0">
                 <a:solidFill>
                   <a:srgbClr val="8DA0B5"/>
                 </a:solidFill>
                 <a:latin typeface="Inter"/>
               </a:rPr>
-              <a:t>10</a:t>
-            </a:r>
-          </a:p>
-        </p:txBody>
-      </p:sp>
-    </p:spTree>
-  </p:cSld>
-  <p:clrMapOvr>
-    <a:masterClrMapping/>
-  </p:clrMapOvr>
-</p:sld>
-</file>
-
-<file path=ppt/slides/slide11.xml><?xml version="1.0" encoding="utf-8"?>
-<p:sld xmlns:a="http://schemas.openxmlformats.org/drawingml/2006/main" xmlns:p="http://schemas.openxmlformats.org/presentationml/2006/main" xmlns:r="http://schemas.openxmlformats.org/officeDocument/2006/relationships">
-  <p:cSld>
-    <p:bg>
-      <p:bgPr>
-        <a:solidFill>
-          <a:srgbClr val="0B2545"/>
-        </a:solidFill>
-        <a:effectLst/>
-      </p:bgPr>
-    </p:bg>
-    <p:spTree>
-      <p:nvGrpSpPr>
-        <p:cNvPr id="1" name=""/>
-        <p:cNvGrpSpPr/>
-        <p:nvPr/>
-      </p:nvGrpSpPr>
-      <p:grpSpPr/>
-      <p:sp>
-        <p:nvSpPr>
-          <p:cNvPr id="2" name="Rectangle 1"/>
-          <p:cNvSpPr/>
-          <p:nvPr/>
-        </p:nvSpPr>
-        <p:spPr>
-          <a:xfrm>
-            <a:off x="0" y="0"/>
-            <a:ext cx="146304" cy="6858000"/>
-          </a:xfrm>
-          <a:prstGeom prst="rect">
-            <a:avLst/>
-          </a:prstGeom>
-          <a:solidFill>
-            <a:srgbClr val="3E8E68"/>
-          </a:solidFill>
-          <a:ln>
-            <a:noFill/>
-          </a:ln>
-          <a:effectLst/>
-        </p:spPr>
-        <p:style>
-          <a:lnRef idx="1">
-            <a:schemeClr val="accent1"/>
-          </a:lnRef>
-          <a:fillRef idx="3">
-            <a:schemeClr val="accent1"/>
-          </a:fillRef>
-          <a:effectRef idx="2">
-            <a:schemeClr val="accent1"/>
-          </a:effectRef>
-          <a:fontRef idx="minor">
-            <a:schemeClr val="lt1"/>
-          </a:fontRef>
-        </p:style>
-        <p:txBody>
-          <a:bodyPr rtlCol="0" anchor="ctr" wrap="square"/>
-          <a:lstStyle/>
-          <a:p>
-            <a:pPr algn="ctr"/>
-          </a:p>
-        </p:txBody>
-      </p:sp>
-      <p:sp>
-        <p:nvSpPr>
-          <p:cNvPr id="3" name="TextBox 2"/>
-          <p:cNvSpPr txBox="1"/>
-          <p:nvPr/>
-        </p:nvSpPr>
-        <p:spPr>
-          <a:xfrm>
-            <a:off x="868680" y="2148840"/>
-            <a:ext cx="8229600" cy="320040"/>
-          </a:xfrm>
-          <a:prstGeom prst="rect">
-            <a:avLst/>
-          </a:prstGeom>
-          <a:noFill/>
-        </p:spPr>
-        <p:txBody>
-          <a:bodyPr wrap="square" anchor="t" lIns="0" rIns="0" tIns="0" bIns="0">
-            <a:spAutoFit/>
-          </a:bodyPr>
-          <a:lstStyle/>
+              <a:t>François Bernard   ·   Pierre Gellet</a:t>
+            </a:r>
+          </a:p>
           <a:p>
             <a:pPr algn="l">
               <a:lnSpc>
                 <a:spcPct val="125000"/>
               </a:lnSpc>
               <a:spcBef>
-                <a:spcPts val="0"/>
-              </a:spcBef>
-              <a:spcAft>
-                <a:spcPts val="0"/>
-              </a:spcAft>
-            </a:pPr>
-            <a:r>
-              <a:rPr sz="1200" b="1" i="0" spc="220">
-                <a:solidFill>
-                  <a:srgbClr val="8FC7AA"/>
+                <a:spcPts val="800"/>
+              </a:spcBef>
+              <a:spcAft>
+                <a:spcPts val="0"/>
+              </a:spcAft>
+            </a:pPr>
+            <a:r>
+              <a:rPr sz="1150" b="0" i="0" spc="90">
+                <a:solidFill>
+                  <a:srgbClr val="8DA0B5"/>
                 </a:solidFill>
                 <a:latin typeface="Inter"/>
               </a:rPr>
-              <a:t>MERCI</a:t>
-            </a:r>
-          </a:p>
-        </p:txBody>
-      </p:sp>
-      <p:sp>
-        <p:nvSpPr>
-          <p:cNvPr id="4" name="TextBox 3"/>
-          <p:cNvSpPr txBox="1"/>
-          <p:nvPr/>
-        </p:nvSpPr>
-        <p:spPr>
-          <a:xfrm>
-            <a:off x="868680" y="2578608"/>
-            <a:ext cx="10454335" cy="914400"/>
-          </a:xfrm>
-          <a:prstGeom prst="rect">
-            <a:avLst/>
-          </a:prstGeom>
-          <a:noFill/>
-        </p:spPr>
-        <p:txBody>
-          <a:bodyPr wrap="square" anchor="t" lIns="0" rIns="0" tIns="0" bIns="0">
-            <a:spAutoFit/>
-          </a:bodyPr>
-          <a:lstStyle/>
-          <a:p>
-            <a:pPr algn="l">
-              <a:lnSpc>
-                <a:spcPct val="125000"/>
-              </a:lnSpc>
-              <a:spcBef>
-                <a:spcPts val="0"/>
-              </a:spcBef>
-              <a:spcAft>
-                <a:spcPts val="0"/>
-              </a:spcAft>
-            </a:pPr>
-            <a:r>
-              <a:rPr sz="4600" b="1" i="0">
-                <a:solidFill>
-                  <a:srgbClr val="FFFFFF"/>
-                </a:solidFill>
-                <a:latin typeface="Fraunces"/>
-              </a:rPr>
-              <a:t>Des questions ?</a:t>
+              <a:t>HEIG-VD   ·   Projet de groupe   ·   2026</a:t>
             </a:r>
           </a:p>
         </p:txBody>
       </p:sp>
       <p:cxnSp>
         <p:nvCxnSpPr>
-          <p:cNvPr id="5" name="Connector 4"/>
+          <p:cNvPr id="8" name="Connector 7"/>
           <p:cNvCxnSpPr/>
           <p:nvPr/>
         </p:nvCxnSpPr>
         <p:spPr>
           <a:xfrm>
-            <a:off x="868680" y="3794760"/>
-            <a:ext cx="2926080" cy="0"/>
+            <a:off x="868680" y="5440680"/>
+            <a:ext cx="10454335" cy="0"/>
           </a:xfrm>
           <a:prstGeom prst="line">
             <a:avLst/>
           </a:prstGeom>
-          <a:ln w="19050">
+          <a:ln w="12700">
             <a:solidFill>
-              <a:srgbClr val="3E8E68"/>
+              <a:srgbClr val="1C4270"/>
             </a:solidFill>
           </a:ln>
         </p:spPr>
@@ -5100,27 +4923,27 @@
       </p:cxnSp>
       <p:sp>
         <p:nvSpPr>
-          <p:cNvPr id="6" name="TextBox 5"/>
-          <p:cNvSpPr txBox="1"/>
-          <p:nvPr/>
-        </p:nvSpPr>
-        <p:spPr>
-          <a:xfrm>
-            <a:off x="868680" y="4114800"/>
-            <a:ext cx="5120640" cy="1371600"/>
-          </a:xfrm>
-          <a:prstGeom prst="rect">
-            <a:avLst/>
-          </a:prstGeom>
-          <a:noFill/>
-        </p:spPr>
-        <p:txBody>
-          <a:bodyPr wrap="square" anchor="t" lIns="0" rIns="0" tIns="0" bIns="0">
-            <a:spAutoFit/>
-          </a:bodyPr>
-          <a:lstStyle/>
-          <a:p>
-            <a:pPr algn="l">
+          <p:cNvPr id="9" name="TextBox 8"/>
+          <p:cNvSpPr txBox="1"/>
+          <p:nvPr/>
+        </p:nvSpPr>
+        <p:spPr>
+          <a:xfrm>
+            <a:off x="868680" y="5669280"/>
+            <a:ext cx="2090867" cy="310896"/>
+          </a:xfrm>
+          <a:prstGeom prst="rect">
+            <a:avLst/>
+          </a:prstGeom>
+          <a:noFill/>
+        </p:spPr>
+        <p:txBody>
+          <a:bodyPr wrap="square" anchor="t" lIns="0" rIns="0" tIns="0" bIns="0">
+            <a:spAutoFit/>
+          </a:bodyPr>
+          <a:lstStyle/>
+          <a:p>
+            <a:pPr algn="ctr">
               <a:lnSpc>
                 <a:spcPct val="125000"/>
               </a:lnSpc>
@@ -5128,21 +4951,89 @@
                 <a:spcPts val="0"/>
               </a:spcBef>
               <a:spcAft>
-                <a:spcPts val="700"/>
-              </a:spcAft>
-            </a:pPr>
-            <a:r>
-              <a:rPr sz="1450" b="0" i="0">
+                <a:spcPts val="0"/>
+              </a:spcAft>
+            </a:pPr>
+            <a:r>
+              <a:rPr sz="2000" b="1" i="0">
                 <a:solidFill>
                   <a:srgbClr val="FFFFFF"/>
                 </a:solidFill>
+                <a:latin typeface="Fraunces"/>
+              </a:rPr>
+              <a:t>242</a:t>
+            </a:r>
+          </a:p>
+        </p:txBody>
+      </p:sp>
+      <p:sp>
+        <p:nvSpPr>
+          <p:cNvPr id="10" name="TextBox 9"/>
+          <p:cNvSpPr txBox="1"/>
+          <p:nvPr/>
+        </p:nvSpPr>
+        <p:spPr>
+          <a:xfrm>
+            <a:off x="868680" y="5998464"/>
+            <a:ext cx="2090867" cy="237744"/>
+          </a:xfrm>
+          <a:prstGeom prst="rect">
+            <a:avLst/>
+          </a:prstGeom>
+          <a:noFill/>
+        </p:spPr>
+        <p:txBody>
+          <a:bodyPr wrap="square" anchor="t" lIns="0" rIns="0" tIns="0" bIns="0">
+            <a:spAutoFit/>
+          </a:bodyPr>
+          <a:lstStyle/>
+          <a:p>
+            <a:pPr algn="ctr">
+              <a:lnSpc>
+                <a:spcPct val="125000"/>
+              </a:lnSpc>
+              <a:spcBef>
+                <a:spcPts val="0"/>
+              </a:spcBef>
+              <a:spcAft>
+                <a:spcPts val="0"/>
+              </a:spcAft>
+            </a:pPr>
+            <a:r>
+              <a:rPr sz="1000" b="0" i="0">
+                <a:solidFill>
+                  <a:srgbClr val="8DA0B5"/>
+                </a:solidFill>
                 <a:latin typeface="Inter"/>
               </a:rPr>
-              <a:t>github.com/mircoprofico/FitMeet</a:t>
-            </a:r>
-          </a:p>
-          <a:p>
-            <a:pPr algn="l">
+              <a:t>commits</a:t>
+            </a:r>
+          </a:p>
+        </p:txBody>
+      </p:sp>
+      <p:sp>
+        <p:nvSpPr>
+          <p:cNvPr id="11" name="TextBox 10"/>
+          <p:cNvSpPr txBox="1"/>
+          <p:nvPr/>
+        </p:nvSpPr>
+        <p:spPr>
+          <a:xfrm>
+            <a:off x="2959547" y="5669280"/>
+            <a:ext cx="2090867" cy="310896"/>
+          </a:xfrm>
+          <a:prstGeom prst="rect">
+            <a:avLst/>
+          </a:prstGeom>
+          <a:noFill/>
+        </p:spPr>
+        <p:txBody>
+          <a:bodyPr wrap="square" anchor="t" lIns="0" rIns="0" tIns="0" bIns="0">
+            <a:spAutoFit/>
+          </a:bodyPr>
+          <a:lstStyle/>
+          <a:p>
+            <a:pPr algn="ctr">
               <a:lnSpc>
                 <a:spcPct val="125000"/>
               </a:lnSpc>
@@ -5150,44 +5041,89 @@
                 <a:spcPts val="0"/>
               </a:spcBef>
               <a:spcAft>
-                <a:spcPts val="700"/>
-              </a:spcAft>
-            </a:pPr>
-            <a:r>
-              <a:rPr sz="1450" b="0" i="0">
-                <a:solidFill>
-                  <a:srgbClr val="8FC7AA"/>
+                <a:spcPts val="0"/>
+              </a:spcAft>
+            </a:pPr>
+            <a:r>
+              <a:rPr sz="2000" b="1" i="0">
+                <a:solidFill>
+                  <a:srgbClr val="FFFFFF"/>
+                </a:solidFill>
+                <a:latin typeface="Fraunces"/>
+              </a:rPr>
+              <a:t>52</a:t>
+            </a:r>
+          </a:p>
+        </p:txBody>
+      </p:sp>
+      <p:sp>
+        <p:nvSpPr>
+          <p:cNvPr id="12" name="TextBox 11"/>
+          <p:cNvSpPr txBox="1"/>
+          <p:nvPr/>
+        </p:nvSpPr>
+        <p:spPr>
+          <a:xfrm>
+            <a:off x="2959547" y="5998464"/>
+            <a:ext cx="2090867" cy="237744"/>
+          </a:xfrm>
+          <a:prstGeom prst="rect">
+            <a:avLst/>
+          </a:prstGeom>
+          <a:noFill/>
+        </p:spPr>
+        <p:txBody>
+          <a:bodyPr wrap="square" anchor="t" lIns="0" rIns="0" tIns="0" bIns="0">
+            <a:spAutoFit/>
+          </a:bodyPr>
+          <a:lstStyle/>
+          <a:p>
+            <a:pPr algn="ctr">
+              <a:lnSpc>
+                <a:spcPct val="125000"/>
+              </a:lnSpc>
+              <a:spcBef>
+                <a:spcPts val="0"/>
+              </a:spcBef>
+              <a:spcAft>
+                <a:spcPts val="0"/>
+              </a:spcAft>
+            </a:pPr>
+            <a:r>
+              <a:rPr sz="1000" b="0" i="0">
+                <a:solidFill>
+                  <a:srgbClr val="8DA0B5"/>
                 </a:solidFill>
                 <a:latin typeface="Inter"/>
               </a:rPr>
-              <a:t>mircoprofico.github.io/FitMeet</a:t>
-            </a:r>
-          </a:p>
-        </p:txBody>
-      </p:sp>
-      <p:sp>
-        <p:nvSpPr>
-          <p:cNvPr id="7" name="TextBox 6"/>
-          <p:cNvSpPr txBox="1"/>
-          <p:nvPr/>
-        </p:nvSpPr>
-        <p:spPr>
-          <a:xfrm>
-            <a:off x="6766560" y="4114800"/>
-            <a:ext cx="4480560" cy="1463040"/>
-          </a:xfrm>
-          <a:prstGeom prst="rect">
-            <a:avLst/>
-          </a:prstGeom>
-          <a:noFill/>
-        </p:spPr>
-        <p:txBody>
-          <a:bodyPr wrap="square" anchor="t" lIns="0" rIns="0" tIns="0" bIns="0">
-            <a:spAutoFit/>
-          </a:bodyPr>
-          <a:lstStyle/>
-          <a:p>
-            <a:pPr algn="l">
+              <a:t>pull requests</a:t>
+            </a:r>
+          </a:p>
+        </p:txBody>
+      </p:sp>
+      <p:sp>
+        <p:nvSpPr>
+          <p:cNvPr id="13" name="TextBox 12"/>
+          <p:cNvSpPr txBox="1"/>
+          <p:nvPr/>
+        </p:nvSpPr>
+        <p:spPr>
+          <a:xfrm>
+            <a:off x="5050414" y="5669280"/>
+            <a:ext cx="2090867" cy="310896"/>
+          </a:xfrm>
+          <a:prstGeom prst="rect">
+            <a:avLst/>
+          </a:prstGeom>
+          <a:noFill/>
+        </p:spPr>
+        <p:txBody>
+          <a:bodyPr wrap="square" anchor="t" lIns="0" rIns="0" tIns="0" bIns="0">
+            <a:spAutoFit/>
+          </a:bodyPr>
+          <a:lstStyle/>
+          <a:p>
+            <a:pPr algn="ctr">
               <a:lnSpc>
                 <a:spcPct val="125000"/>
               </a:lnSpc>
@@ -5195,21 +5131,89 @@
                 <a:spcPts val="0"/>
               </a:spcBef>
               <a:spcAft>
-                <a:spcPts val="600"/>
-              </a:spcAft>
-            </a:pPr>
-            <a:r>
-              <a:rPr sz="1300" b="0" i="0">
+                <a:spcPts val="0"/>
+              </a:spcAft>
+            </a:pPr>
+            <a:r>
+              <a:rPr sz="2000" b="1" i="0">
+                <a:solidFill>
+                  <a:srgbClr val="FFFFFF"/>
+                </a:solidFill>
+                <a:latin typeface="Fraunces"/>
+              </a:rPr>
+              <a:t>35</a:t>
+            </a:r>
+          </a:p>
+        </p:txBody>
+      </p:sp>
+      <p:sp>
+        <p:nvSpPr>
+          <p:cNvPr id="14" name="TextBox 13"/>
+          <p:cNvSpPr txBox="1"/>
+          <p:nvPr/>
+        </p:nvSpPr>
+        <p:spPr>
+          <a:xfrm>
+            <a:off x="5050414" y="5998464"/>
+            <a:ext cx="2090867" cy="237744"/>
+          </a:xfrm>
+          <a:prstGeom prst="rect">
+            <a:avLst/>
+          </a:prstGeom>
+          <a:noFill/>
+        </p:spPr>
+        <p:txBody>
+          <a:bodyPr wrap="square" anchor="t" lIns="0" rIns="0" tIns="0" bIns="0">
+            <a:spAutoFit/>
+          </a:bodyPr>
+          <a:lstStyle/>
+          <a:p>
+            <a:pPr algn="ctr">
+              <a:lnSpc>
+                <a:spcPct val="125000"/>
+              </a:lnSpc>
+              <a:spcBef>
+                <a:spcPts val="0"/>
+              </a:spcBef>
+              <a:spcAft>
+                <a:spcPts val="0"/>
+              </a:spcAft>
+            </a:pPr>
+            <a:r>
+              <a:rPr sz="1000" b="0" i="0">
                 <a:solidFill>
                   <a:srgbClr val="8DA0B5"/>
                 </a:solidFill>
                 <a:latin typeface="Inter"/>
               </a:rPr>
-              <a:t>Mirco Profico   ·   Antoine Aubry</a:t>
-            </a:r>
-          </a:p>
-          <a:p>
-            <a:pPr algn="l">
+              <a:t>releases</a:t>
+            </a:r>
+          </a:p>
+        </p:txBody>
+      </p:sp>
+      <p:sp>
+        <p:nvSpPr>
+          <p:cNvPr id="15" name="TextBox 14"/>
+          <p:cNvSpPr txBox="1"/>
+          <p:nvPr/>
+        </p:nvSpPr>
+        <p:spPr>
+          <a:xfrm>
+            <a:off x="7141281" y="5669280"/>
+            <a:ext cx="2090867" cy="310896"/>
+          </a:xfrm>
+          <a:prstGeom prst="rect">
+            <a:avLst/>
+          </a:prstGeom>
+          <a:noFill/>
+        </p:spPr>
+        <p:txBody>
+          <a:bodyPr wrap="square" anchor="t" lIns="0" rIns="0" tIns="0" bIns="0">
+            <a:spAutoFit/>
+          </a:bodyPr>
+          <a:lstStyle/>
+          <a:p>
+            <a:pPr algn="ctr">
               <a:lnSpc>
                 <a:spcPct val="125000"/>
               </a:lnSpc>
@@ -5217,46 +5221,159 @@
                 <a:spcPts val="0"/>
               </a:spcBef>
               <a:spcAft>
-                <a:spcPts val="600"/>
-              </a:spcAft>
-            </a:pPr>
-            <a:r>
-              <a:rPr sz="1300" b="0" i="0">
+                <a:spcPts val="0"/>
+              </a:spcAft>
+            </a:pPr>
+            <a:r>
+              <a:rPr sz="2000" b="1" i="0">
+                <a:solidFill>
+                  <a:srgbClr val="FFFFFF"/>
+                </a:solidFill>
+                <a:latin typeface="Fraunces"/>
+              </a:rPr>
+              <a:t>19</a:t>
+            </a:r>
+          </a:p>
+        </p:txBody>
+      </p:sp>
+      <p:sp>
+        <p:nvSpPr>
+          <p:cNvPr id="16" name="TextBox 15"/>
+          <p:cNvSpPr txBox="1"/>
+          <p:nvPr/>
+        </p:nvSpPr>
+        <p:spPr>
+          <a:xfrm>
+            <a:off x="7141281" y="5998464"/>
+            <a:ext cx="2090867" cy="237744"/>
+          </a:xfrm>
+          <a:prstGeom prst="rect">
+            <a:avLst/>
+          </a:prstGeom>
+          <a:noFill/>
+        </p:spPr>
+        <p:txBody>
+          <a:bodyPr wrap="square" anchor="t" lIns="0" rIns="0" tIns="0" bIns="0">
+            <a:spAutoFit/>
+          </a:bodyPr>
+          <a:lstStyle/>
+          <a:p>
+            <a:pPr algn="ctr">
+              <a:lnSpc>
+                <a:spcPct val="125000"/>
+              </a:lnSpc>
+              <a:spcBef>
+                <a:spcPts val="0"/>
+              </a:spcBef>
+              <a:spcAft>
+                <a:spcPts val="0"/>
+              </a:spcAft>
+            </a:pPr>
+            <a:r>
+              <a:rPr sz="1000" b="0" i="0">
                 <a:solidFill>
                   <a:srgbClr val="8DA0B5"/>
                 </a:solidFill>
                 <a:latin typeface="Inter"/>
               </a:rPr>
-              <a:t>François Bernard   ·   Pierre Gellet</a:t>
-            </a:r>
-          </a:p>
-          <a:p>
-            <a:pPr algn="l">
+              <a:t>migrations</a:t>
+            </a:r>
+          </a:p>
+        </p:txBody>
+      </p:sp>
+      <p:sp>
+        <p:nvSpPr>
+          <p:cNvPr id="17" name="TextBox 16"/>
+          <p:cNvSpPr txBox="1"/>
+          <p:nvPr/>
+        </p:nvSpPr>
+        <p:spPr>
+          <a:xfrm>
+            <a:off x="9232148" y="5669280"/>
+            <a:ext cx="2090867" cy="310896"/>
+          </a:xfrm>
+          <a:prstGeom prst="rect">
+            <a:avLst/>
+          </a:prstGeom>
+          <a:noFill/>
+        </p:spPr>
+        <p:txBody>
+          <a:bodyPr wrap="square" anchor="t" lIns="0" rIns="0" tIns="0" bIns="0">
+            <a:spAutoFit/>
+          </a:bodyPr>
+          <a:lstStyle/>
+          <a:p>
+            <a:pPr algn="ctr">
               <a:lnSpc>
                 <a:spcPct val="125000"/>
               </a:lnSpc>
               <a:spcBef>
-                <a:spcPts val="800"/>
-              </a:spcBef>
-              <a:spcAft>
-                <a:spcPts val="0"/>
-              </a:spcAft>
-            </a:pPr>
-            <a:r>
-              <a:rPr sz="1150" b="0" i="0" spc="90">
+                <a:spcPts val="0"/>
+              </a:spcBef>
+              <a:spcAft>
+                <a:spcPts val="0"/>
+              </a:spcAft>
+            </a:pPr>
+            <a:r>
+              <a:rPr sz="2000" b="1" i="0">
+                <a:solidFill>
+                  <a:srgbClr val="FFFFFF"/>
+                </a:solidFill>
+                <a:latin typeface="Fraunces"/>
+              </a:rPr>
+              <a:t>6 044</a:t>
+            </a:r>
+          </a:p>
+        </p:txBody>
+      </p:sp>
+      <p:sp>
+        <p:nvSpPr>
+          <p:cNvPr id="18" name="TextBox 17"/>
+          <p:cNvSpPr txBox="1"/>
+          <p:nvPr/>
+        </p:nvSpPr>
+        <p:spPr>
+          <a:xfrm>
+            <a:off x="9232148" y="5998464"/>
+            <a:ext cx="2090867" cy="237744"/>
+          </a:xfrm>
+          <a:prstGeom prst="rect">
+            <a:avLst/>
+          </a:prstGeom>
+          <a:noFill/>
+        </p:spPr>
+        <p:txBody>
+          <a:bodyPr wrap="square" anchor="t" lIns="0" rIns="0" tIns="0" bIns="0">
+            <a:spAutoFit/>
+          </a:bodyPr>
+          <a:lstStyle/>
+          <a:p>
+            <a:pPr algn="ctr">
+              <a:lnSpc>
+                <a:spcPct val="125000"/>
+              </a:lnSpc>
+              <a:spcBef>
+                <a:spcPts val="0"/>
+              </a:spcBef>
+              <a:spcAft>
+                <a:spcPts val="0"/>
+              </a:spcAft>
+            </a:pPr>
+            <a:r>
+              <a:rPr sz="1000" b="0" i="0">
                 <a:solidFill>
                   <a:srgbClr val="8DA0B5"/>
                 </a:solidFill>
                 <a:latin typeface="Inter"/>
               </a:rPr>
-              <a:t>HEIG-VD   ·   Projet de groupe   ·   2026</a:t>
-            </a:r>
-          </a:p>
-        </p:txBody>
-      </p:sp>
-      <p:sp>
-        <p:nvSpPr>
-          <p:cNvPr id="8" name="TextBox 7"/>
+              <a:t>lignes de Kotlin</a:t>
+            </a:r>
+          </a:p>
+        </p:txBody>
+      </p:sp>
+      <p:sp>
+        <p:nvSpPr>
+          <p:cNvPr id="19" name="TextBox 18"/>
           <p:cNvSpPr txBox="1"/>
           <p:nvPr/>
         </p:nvSpPr>
@@ -5294,7 +5411,7 @@
                 </a:solidFill>
                 <a:latin typeface="Inter"/>
               </a:rPr>
-              <a:t>11</a:t>
+              <a:t>10</a:t>
             </a:r>
           </a:p>
         </p:txBody>
@@ -13614,7 +13731,7 @@
     <p:bg>
       <p:bgPr>
         <a:solidFill>
-          <a:srgbClr val="F4F6F5"/>
+          <a:srgbClr val="2E6B4E"/>
         </a:solidFill>
         <a:effectLst/>
       </p:bgPr>
@@ -13634,8 +13751,8 @@
         </p:nvSpPr>
         <p:spPr>
           <a:xfrm>
-            <a:off x="868680" y="713232"/>
-            <a:ext cx="10454335" cy="237744"/>
+            <a:off x="868680" y="2286000"/>
+            <a:ext cx="5852160" cy="320040"/>
           </a:xfrm>
           <a:prstGeom prst="rect">
             <a:avLst/>
@@ -13660,13 +13777,13 @@
               </a:spcAft>
             </a:pPr>
             <a:r>
-              <a:rPr sz="1050" b="1" i="0" spc="170">
-                <a:solidFill>
-                  <a:srgbClr val="3E8E68"/>
+              <a:rPr sz="1100" b="1" i="0" spc="190">
+                <a:solidFill>
+                  <a:srgbClr val="8FC7AA"/>
                 </a:solidFill>
                 <a:latin typeface="Inter"/>
               </a:rPr>
-              <a:t>TESTS ET LIMITES</a:t>
+              <a:t>DÉMONSTRATION</a:t>
             </a:r>
           </a:p>
         </p:txBody>
@@ -13679,8 +13796,8 @@
         </p:nvSpPr>
         <p:spPr>
           <a:xfrm>
-            <a:off x="868680" y="1042415"/>
-            <a:ext cx="10454335" cy="1005840"/>
+            <a:off x="868680" y="2743200"/>
+            <a:ext cx="10454335" cy="914400"/>
           </a:xfrm>
           <a:prstGeom prst="rect">
             <a:avLst/>
@@ -13695,75 +13812,62 @@
           <a:p>
             <a:pPr algn="l">
               <a:lnSpc>
-                <a:spcPct val="112000"/>
-              </a:lnSpc>
-              <a:spcBef>
-                <a:spcPts val="0"/>
-              </a:spcBef>
-              <a:spcAft>
-                <a:spcPts val="0"/>
-              </a:spcAft>
-            </a:pPr>
-            <a:r>
-              <a:rPr sz="3200" b="1" i="0">
-                <a:solidFill>
-                  <a:srgbClr val="16233A"/>
+                <a:spcPct val="125000"/>
+              </a:lnSpc>
+              <a:spcBef>
+                <a:spcPts val="0"/>
+              </a:spcBef>
+              <a:spcAft>
+                <a:spcPts val="0"/>
+              </a:spcAft>
+            </a:pPr>
+            <a:r>
+              <a:rPr sz="4400" b="1" i="0">
+                <a:solidFill>
+                  <a:srgbClr val="FFFFFF"/>
                 </a:solidFill>
                 <a:latin typeface="Fraunces"/>
               </a:rPr>
-              <a:t>Ce que nous testons, ce que nous n'avons pas fait</a:t>
-            </a:r>
-          </a:p>
-        </p:txBody>
-      </p:sp>
-      <p:sp>
-        <p:nvSpPr>
-          <p:cNvPr id="4" name="Rounded Rectangle 3"/>
-          <p:cNvSpPr/>
-          <p:nvPr/>
-        </p:nvSpPr>
-        <p:spPr>
-          <a:xfrm>
-            <a:off x="2148840" y="2011680"/>
-            <a:ext cx="2011680" cy="768096"/>
-          </a:xfrm>
-          <a:prstGeom prst="roundRect">
-            <a:avLst>
-              <a:gd name="adj" fmla="val 8000"/>
-            </a:avLst>
-          </a:prstGeom>
-          <a:solidFill>
-            <a:srgbClr val="FBEDE7"/>
-          </a:solidFill>
-          <a:ln w="12700">
+              <a:t>L'application</a:t>
+            </a:r>
+          </a:p>
+        </p:txBody>
+      </p:sp>
+      <p:cxnSp>
+        <p:nvCxnSpPr>
+          <p:cNvPr id="4" name="Connector 3"/>
+          <p:cNvCxnSpPr/>
+          <p:nvPr/>
+        </p:nvCxnSpPr>
+        <p:spPr>
+          <a:xfrm>
+            <a:off x="868680" y="3931920"/>
+            <a:ext cx="2377440" cy="0"/>
+          </a:xfrm>
+          <a:prstGeom prst="line">
+            <a:avLst/>
+          </a:prstGeom>
+          <a:ln w="19050">
             <a:solidFill>
-              <a:srgbClr val="E0623C"/>
+              <a:srgbClr val="8FC7AA"/>
             </a:solidFill>
           </a:ln>
-          <a:effectLst/>
         </p:spPr>
         <p:style>
-          <a:lnRef idx="1">
+          <a:lnRef idx="2">
             <a:schemeClr val="accent1"/>
           </a:lnRef>
-          <a:fillRef idx="3">
+          <a:fillRef idx="0">
             <a:schemeClr val="accent1"/>
           </a:fillRef>
-          <a:effectRef idx="2">
+          <a:effectRef idx="1">
             <a:schemeClr val="accent1"/>
           </a:effectRef>
           <a:fontRef idx="minor">
-            <a:schemeClr val="lt1"/>
+            <a:schemeClr val="tx1"/>
           </a:fontRef>
         </p:style>
-        <p:txBody>
-          <a:bodyPr rtlCol="0" anchor="ctr" wrap="square"/>
-          <a:lstStyle/>
-          <a:p>
-            <a:pPr algn="ctr"/>
-          </a:p>
-        </p:txBody>
-      </p:sp>
+      </p:cxnSp>
       <p:sp>
         <p:nvSpPr>
           <p:cNvPr id="5" name="TextBox 4"/>
@@ -13772,39 +13876,83 @@
         </p:nvSpPr>
         <p:spPr>
           <a:xfrm>
-            <a:off x="2148840" y="2139696"/>
-            <a:ext cx="2011680" cy="274320"/>
-          </a:xfrm>
-          <a:prstGeom prst="rect">
-            <a:avLst/>
-          </a:prstGeom>
-          <a:noFill/>
-        </p:spPr>
-        <p:txBody>
-          <a:bodyPr wrap="square" anchor="t" lIns="0" rIns="0" tIns="0" bIns="0">
-            <a:spAutoFit/>
-          </a:bodyPr>
-          <a:lstStyle/>
-          <a:p>
-            <a:pPr algn="ctr">
-              <a:lnSpc>
-                <a:spcPct val="125000"/>
-              </a:lnSpc>
-              <a:spcBef>
-                <a:spcPts val="0"/>
-              </a:spcBef>
-              <a:spcAft>
-                <a:spcPts val="0"/>
-              </a:spcAft>
-            </a:pPr>
-            <a:r>
-              <a:rPr sz="1350" b="1" i="0">
-                <a:solidFill>
-                  <a:srgbClr val="16233A"/>
+            <a:off x="868680" y="4206240"/>
+            <a:ext cx="7132320" cy="1645920"/>
+          </a:xfrm>
+          <a:prstGeom prst="rect">
+            <a:avLst/>
+          </a:prstGeom>
+          <a:noFill/>
+        </p:spPr>
+        <p:txBody>
+          <a:bodyPr wrap="square" anchor="t" lIns="0" rIns="0" tIns="0" bIns="0">
+            <a:spAutoFit/>
+          </a:bodyPr>
+          <a:lstStyle/>
+          <a:p>
+            <a:pPr algn="l">
+              <a:lnSpc>
+                <a:spcPct val="140000"/>
+              </a:lnSpc>
+              <a:spcBef>
+                <a:spcPts val="0"/>
+              </a:spcBef>
+              <a:spcAft>
+                <a:spcPts val="900"/>
+              </a:spcAft>
+            </a:pPr>
+            <a:r>
+              <a:rPr sz="1550" b="0" i="0">
+                <a:solidFill>
+                  <a:srgbClr val="FFFFFF"/>
                 </a:solidFill>
                 <a:latin typeface="Inter"/>
               </a:rPr>
-              <a:t>Bout en bout</a:t>
+              <a:t>—   Je crée une séance de badminton à Yverdon.</a:t>
+            </a:r>
+          </a:p>
+          <a:p>
+            <a:pPr algn="l">
+              <a:lnSpc>
+                <a:spcPct val="140000"/>
+              </a:lnSpc>
+              <a:spcBef>
+                <a:spcPts val="0"/>
+              </a:spcBef>
+              <a:spcAft>
+                <a:spcPts val="900"/>
+              </a:spcAft>
+            </a:pPr>
+            <a:r>
+              <a:rPr sz="1550" b="0" i="0">
+                <a:solidFill>
+                  <a:srgbClr val="FFFFFF"/>
+                </a:solidFill>
+                <a:latin typeface="Inter"/>
+              </a:rPr>
+              <a:t>—   Elle apparaît dans la liste et sur la carte.</a:t>
+            </a:r>
+          </a:p>
+          <a:p>
+            <a:pPr algn="l">
+              <a:lnSpc>
+                <a:spcPct val="140000"/>
+              </a:lnSpc>
+              <a:spcBef>
+                <a:spcPts val="0"/>
+              </a:spcBef>
+              <a:spcAft>
+                <a:spcPts val="900"/>
+              </a:spcAft>
+            </a:pPr>
+            <a:r>
+              <a:rPr sz="1550" b="0" i="0">
+                <a:solidFill>
+                  <a:srgbClr val="FFFFFF"/>
+                </a:solidFill>
+                <a:latin typeface="Inter"/>
+              </a:rPr>
+              <a:t>—   Un deuxième compte la rejoint : la place disparaît.</a:t>
             </a:r>
           </a:p>
         </p:txBody>
@@ -13812,1138 +13960,6 @@
       <p:sp>
         <p:nvSpPr>
           <p:cNvPr id="6" name="TextBox 5"/>
-          <p:cNvSpPr txBox="1"/>
-          <p:nvPr/>
-        </p:nvSpPr>
-        <p:spPr>
-          <a:xfrm>
-            <a:off x="2148840" y="2404872"/>
-            <a:ext cx="2011680" cy="365760"/>
-          </a:xfrm>
-          <a:prstGeom prst="rect">
-            <a:avLst/>
-          </a:prstGeom>
-          <a:noFill/>
-        </p:spPr>
-        <p:txBody>
-          <a:bodyPr wrap="square" anchor="t" lIns="0" rIns="0" tIns="0" bIns="0">
-            <a:spAutoFit/>
-          </a:bodyPr>
-          <a:lstStyle/>
-          <a:p>
-            <a:pPr algn="ctr">
-              <a:lnSpc>
-                <a:spcPct val="130000"/>
-              </a:lnSpc>
-              <a:spcBef>
-                <a:spcPts val="0"/>
-              </a:spcBef>
-              <a:spcAft>
-                <a:spcPts val="0"/>
-              </a:spcAft>
-            </a:pPr>
-            <a:r>
-              <a:rPr sz="1000" b="0" i="0">
-                <a:solidFill>
-                  <a:srgbClr val="5B6B7E"/>
-                </a:solidFill>
-                <a:latin typeface="Inter"/>
-              </a:rPr>
-              <a:t>Manuel, sur appareil réel</a:t>
-            </a:r>
-          </a:p>
-        </p:txBody>
-      </p:sp>
-      <p:sp>
-        <p:nvSpPr>
-          <p:cNvPr id="7" name="Rounded Rectangle 6"/>
-          <p:cNvSpPr/>
-          <p:nvPr/>
-        </p:nvSpPr>
-        <p:spPr>
-          <a:xfrm>
-            <a:off x="1554480" y="2926080"/>
-            <a:ext cx="3200400" cy="768096"/>
-          </a:xfrm>
-          <a:prstGeom prst="roundRect">
-            <a:avLst>
-              <a:gd name="adj" fmla="val 8000"/>
-            </a:avLst>
-          </a:prstGeom>
-          <a:solidFill>
-            <a:srgbClr val="E7F1EC"/>
-          </a:solidFill>
-          <a:ln w="12700">
-            <a:solidFill>
-              <a:srgbClr val="3E8E68"/>
-            </a:solidFill>
-          </a:ln>
-          <a:effectLst/>
-        </p:spPr>
-        <p:style>
-          <a:lnRef idx="1">
-            <a:schemeClr val="accent1"/>
-          </a:lnRef>
-          <a:fillRef idx="3">
-            <a:schemeClr val="accent1"/>
-          </a:fillRef>
-          <a:effectRef idx="2">
-            <a:schemeClr val="accent1"/>
-          </a:effectRef>
-          <a:fontRef idx="minor">
-            <a:schemeClr val="lt1"/>
-          </a:fontRef>
-        </p:style>
-        <p:txBody>
-          <a:bodyPr rtlCol="0" anchor="ctr" wrap="square"/>
-          <a:lstStyle/>
-          <a:p>
-            <a:pPr algn="ctr"/>
-          </a:p>
-        </p:txBody>
-      </p:sp>
-      <p:sp>
-        <p:nvSpPr>
-          <p:cNvPr id="8" name="TextBox 7"/>
-          <p:cNvSpPr txBox="1"/>
-          <p:nvPr/>
-        </p:nvSpPr>
-        <p:spPr>
-          <a:xfrm>
-            <a:off x="1554480" y="3054096"/>
-            <a:ext cx="3200400" cy="274320"/>
-          </a:xfrm>
-          <a:prstGeom prst="rect">
-            <a:avLst/>
-          </a:prstGeom>
-          <a:noFill/>
-        </p:spPr>
-        <p:txBody>
-          <a:bodyPr wrap="square" anchor="t" lIns="0" rIns="0" tIns="0" bIns="0">
-            <a:spAutoFit/>
-          </a:bodyPr>
-          <a:lstStyle/>
-          <a:p>
-            <a:pPr algn="ctr">
-              <a:lnSpc>
-                <a:spcPct val="125000"/>
-              </a:lnSpc>
-              <a:spcBef>
-                <a:spcPts val="0"/>
-              </a:spcBef>
-              <a:spcAft>
-                <a:spcPts val="0"/>
-              </a:spcAft>
-            </a:pPr>
-            <a:r>
-              <a:rPr sz="1350" b="1" i="0">
-                <a:solidFill>
-                  <a:srgbClr val="16233A"/>
-                </a:solidFill>
-                <a:latin typeface="Inter"/>
-              </a:rPr>
-              <a:t>Intégration</a:t>
-            </a:r>
-          </a:p>
-        </p:txBody>
-      </p:sp>
-      <p:sp>
-        <p:nvSpPr>
-          <p:cNvPr id="9" name="TextBox 8"/>
-          <p:cNvSpPr txBox="1"/>
-          <p:nvPr/>
-        </p:nvSpPr>
-        <p:spPr>
-          <a:xfrm>
-            <a:off x="1554480" y="3319272"/>
-            <a:ext cx="3200400" cy="365760"/>
-          </a:xfrm>
-          <a:prstGeom prst="rect">
-            <a:avLst/>
-          </a:prstGeom>
-          <a:noFill/>
-        </p:spPr>
-        <p:txBody>
-          <a:bodyPr wrap="square" anchor="t" lIns="0" rIns="0" tIns="0" bIns="0">
-            <a:spAutoFit/>
-          </a:bodyPr>
-          <a:lstStyle/>
-          <a:p>
-            <a:pPr algn="ctr">
-              <a:lnSpc>
-                <a:spcPct val="130000"/>
-              </a:lnSpc>
-              <a:spcBef>
-                <a:spcPts val="0"/>
-              </a:spcBef>
-              <a:spcAft>
-                <a:spcPts val="0"/>
-              </a:spcAft>
-            </a:pPr>
-            <a:r>
-              <a:rPr sz="1000" b="0" i="0">
-                <a:solidFill>
-                  <a:srgbClr val="5B6B7E"/>
-                </a:solidFill>
-                <a:latin typeface="Inter"/>
-              </a:rPr>
-              <a:t>Migrations SQL rejouées sur une base vierge</a:t>
-            </a:r>
-          </a:p>
-        </p:txBody>
-      </p:sp>
-      <p:sp>
-        <p:nvSpPr>
-          <p:cNvPr id="10" name="Rounded Rectangle 9"/>
-          <p:cNvSpPr/>
-          <p:nvPr/>
-        </p:nvSpPr>
-        <p:spPr>
-          <a:xfrm>
-            <a:off x="868680" y="3840480"/>
-            <a:ext cx="4572000" cy="768096"/>
-          </a:xfrm>
-          <a:prstGeom prst="roundRect">
-            <a:avLst>
-              <a:gd name="adj" fmla="val 8000"/>
-            </a:avLst>
-          </a:prstGeom>
-          <a:solidFill>
-            <a:srgbClr val="FFFFFF"/>
-          </a:solidFill>
-          <a:ln w="12700">
-            <a:solidFill>
-              <a:srgbClr val="DEE5E2"/>
-            </a:solidFill>
-          </a:ln>
-          <a:effectLst/>
-        </p:spPr>
-        <p:style>
-          <a:lnRef idx="1">
-            <a:schemeClr val="accent1"/>
-          </a:lnRef>
-          <a:fillRef idx="3">
-            <a:schemeClr val="accent1"/>
-          </a:fillRef>
-          <a:effectRef idx="2">
-            <a:schemeClr val="accent1"/>
-          </a:effectRef>
-          <a:fontRef idx="minor">
-            <a:schemeClr val="lt1"/>
-          </a:fontRef>
-        </p:style>
-        <p:txBody>
-          <a:bodyPr rtlCol="0" anchor="ctr" wrap="square"/>
-          <a:lstStyle/>
-          <a:p>
-            <a:pPr algn="ctr"/>
-          </a:p>
-        </p:txBody>
-      </p:sp>
-      <p:sp>
-        <p:nvSpPr>
-          <p:cNvPr id="11" name="TextBox 10"/>
-          <p:cNvSpPr txBox="1"/>
-          <p:nvPr/>
-        </p:nvSpPr>
-        <p:spPr>
-          <a:xfrm>
-            <a:off x="868680" y="3968496"/>
-            <a:ext cx="4572000" cy="274320"/>
-          </a:xfrm>
-          <a:prstGeom prst="rect">
-            <a:avLst/>
-          </a:prstGeom>
-          <a:noFill/>
-        </p:spPr>
-        <p:txBody>
-          <a:bodyPr wrap="square" anchor="t" lIns="0" rIns="0" tIns="0" bIns="0">
-            <a:spAutoFit/>
-          </a:bodyPr>
-          <a:lstStyle/>
-          <a:p>
-            <a:pPr algn="ctr">
-              <a:lnSpc>
-                <a:spcPct val="125000"/>
-              </a:lnSpc>
-              <a:spcBef>
-                <a:spcPts val="0"/>
-              </a:spcBef>
-              <a:spcAft>
-                <a:spcPts val="0"/>
-              </a:spcAft>
-            </a:pPr>
-            <a:r>
-              <a:rPr sz="1350" b="1" i="0">
-                <a:solidFill>
-                  <a:srgbClr val="16233A"/>
-                </a:solidFill>
-                <a:latin typeface="Inter"/>
-              </a:rPr>
-              <a:t>Unitaires</a:t>
-            </a:r>
-          </a:p>
-        </p:txBody>
-      </p:sp>
-      <p:sp>
-        <p:nvSpPr>
-          <p:cNvPr id="12" name="TextBox 11"/>
-          <p:cNvSpPr txBox="1"/>
-          <p:nvPr/>
-        </p:nvSpPr>
-        <p:spPr>
-          <a:xfrm>
-            <a:off x="868680" y="4233672"/>
-            <a:ext cx="4572000" cy="365760"/>
-          </a:xfrm>
-          <a:prstGeom prst="rect">
-            <a:avLst/>
-          </a:prstGeom>
-          <a:noFill/>
-        </p:spPr>
-        <p:txBody>
-          <a:bodyPr wrap="square" anchor="t" lIns="0" rIns="0" tIns="0" bIns="0">
-            <a:spAutoFit/>
-          </a:bodyPr>
-          <a:lstStyle/>
-          <a:p>
-            <a:pPr algn="ctr">
-              <a:lnSpc>
-                <a:spcPct val="130000"/>
-              </a:lnSpc>
-              <a:spcBef>
-                <a:spcPts val="0"/>
-              </a:spcBef>
-              <a:spcAft>
-                <a:spcPts val="0"/>
-              </a:spcAft>
-            </a:pPr>
-            <a:r>
-              <a:rPr sz="1000" b="0" i="0">
-                <a:solidFill>
-                  <a:srgbClr val="5B6B7E"/>
-                </a:solidFill>
-                <a:latin typeface="Inter"/>
-              </a:rPr>
-              <a:t>8 tests partagés : filtres, tri par distance, onboarding</a:t>
-            </a:r>
-          </a:p>
-        </p:txBody>
-      </p:sp>
-      <p:sp>
-        <p:nvSpPr>
-          <p:cNvPr id="13" name="TextBox 12"/>
-          <p:cNvSpPr txBox="1"/>
-          <p:nvPr/>
-        </p:nvSpPr>
-        <p:spPr>
-          <a:xfrm>
-            <a:off x="868680" y="4754880"/>
-            <a:ext cx="4572000" cy="548640"/>
-          </a:xfrm>
-          <a:prstGeom prst="rect">
-            <a:avLst/>
-          </a:prstGeom>
-          <a:noFill/>
-        </p:spPr>
-        <p:txBody>
-          <a:bodyPr wrap="square" anchor="t" lIns="0" rIns="0" tIns="0" bIns="0">
-            <a:spAutoFit/>
-          </a:bodyPr>
-          <a:lstStyle/>
-          <a:p>
-            <a:pPr algn="l">
-              <a:lnSpc>
-                <a:spcPct val="150000"/>
-              </a:lnSpc>
-              <a:spcBef>
-                <a:spcPts val="0"/>
-              </a:spcBef>
-              <a:spcAft>
-                <a:spcPts val="0"/>
-              </a:spcAft>
-            </a:pPr>
-            <a:r>
-              <a:rPr sz="1200" b="0" i="0">
-                <a:solidFill>
-                  <a:srgbClr val="5B6B7E"/>
-                </a:solidFill>
-                <a:latin typeface="Inter"/>
-              </a:rPr>
-              <a:t>Les tests vivent dans commonTest et s'exécutent sur les deux plateformes, à chaque pull request.</a:t>
-            </a:r>
-          </a:p>
-        </p:txBody>
-      </p:sp>
-      <p:sp>
-        <p:nvSpPr>
-          <p:cNvPr id="14" name="TextBox 13"/>
-          <p:cNvSpPr txBox="1"/>
-          <p:nvPr/>
-        </p:nvSpPr>
-        <p:spPr>
-          <a:xfrm>
-            <a:off x="6080760" y="2011680"/>
-            <a:ext cx="5242255" cy="256032"/>
-          </a:xfrm>
-          <a:prstGeom prst="rect">
-            <a:avLst/>
-          </a:prstGeom>
-          <a:noFill/>
-        </p:spPr>
-        <p:txBody>
-          <a:bodyPr wrap="square" anchor="t" lIns="0" rIns="0" tIns="0" bIns="0">
-            <a:spAutoFit/>
-          </a:bodyPr>
-          <a:lstStyle/>
-          <a:p>
-            <a:pPr algn="l">
-              <a:lnSpc>
-                <a:spcPct val="125000"/>
-              </a:lnSpc>
-              <a:spcBef>
-                <a:spcPts val="0"/>
-              </a:spcBef>
-              <a:spcAft>
-                <a:spcPts val="0"/>
-              </a:spcAft>
-            </a:pPr>
-            <a:r>
-              <a:rPr sz="1300" b="1" i="0">
-                <a:solidFill>
-                  <a:srgbClr val="E0623C"/>
-                </a:solidFill>
-                <a:latin typeface="Inter"/>
-              </a:rPr>
-              <a:t>Notifications push</a:t>
-            </a:r>
-          </a:p>
-        </p:txBody>
-      </p:sp>
-      <p:sp>
-        <p:nvSpPr>
-          <p:cNvPr id="15" name="TextBox 14"/>
-          <p:cNvSpPr txBox="1"/>
-          <p:nvPr/>
-        </p:nvSpPr>
-        <p:spPr>
-          <a:xfrm>
-            <a:off x="6080760" y="2286000"/>
-            <a:ext cx="5242255" cy="457200"/>
-          </a:xfrm>
-          <a:prstGeom prst="rect">
-            <a:avLst/>
-          </a:prstGeom>
-          <a:noFill/>
-        </p:spPr>
-        <p:txBody>
-          <a:bodyPr wrap="square" anchor="t" lIns="0" rIns="0" tIns="0" bIns="0">
-            <a:spAutoFit/>
-          </a:bodyPr>
-          <a:lstStyle/>
-          <a:p>
-            <a:pPr algn="l">
-              <a:lnSpc>
-                <a:spcPct val="140000"/>
-              </a:lnSpc>
-              <a:spcBef>
-                <a:spcPts val="0"/>
-              </a:spcBef>
-              <a:spcAft>
-                <a:spcPts val="0"/>
-              </a:spcAft>
-            </a:pPr>
-            <a:r>
-              <a:rPr sz="1200" b="0" i="0">
-                <a:solidFill>
-                  <a:srgbClr val="5B6B7E"/>
-                </a:solidFill>
-                <a:latin typeface="Inter"/>
-              </a:rPr>
-              <a:t>exigence RF-12, non livrée</a:t>
-            </a:r>
-          </a:p>
-        </p:txBody>
-      </p:sp>
-      <p:sp>
-        <p:nvSpPr>
-          <p:cNvPr id="16" name="TextBox 15"/>
-          <p:cNvSpPr txBox="1"/>
-          <p:nvPr/>
-        </p:nvSpPr>
-        <p:spPr>
-          <a:xfrm>
-            <a:off x="6080760" y="2779776"/>
-            <a:ext cx="5242255" cy="256032"/>
-          </a:xfrm>
-          <a:prstGeom prst="rect">
-            <a:avLst/>
-          </a:prstGeom>
-          <a:noFill/>
-        </p:spPr>
-        <p:txBody>
-          <a:bodyPr wrap="square" anchor="t" lIns="0" rIns="0" tIns="0" bIns="0">
-            <a:spAutoFit/>
-          </a:bodyPr>
-          <a:lstStyle/>
-          <a:p>
-            <a:pPr algn="l">
-              <a:lnSpc>
-                <a:spcPct val="125000"/>
-              </a:lnSpc>
-              <a:spcBef>
-                <a:spcPts val="0"/>
-              </a:spcBef>
-              <a:spcAft>
-                <a:spcPts val="0"/>
-              </a:spcAft>
-            </a:pPr>
-            <a:r>
-              <a:rPr sz="1300" b="1" i="0">
-                <a:solidFill>
-                  <a:srgbClr val="E0623C"/>
-                </a:solidFill>
-                <a:latin typeface="Inter"/>
-              </a:rPr>
-              <a:t>Couverture de tests mince</a:t>
-            </a:r>
-          </a:p>
-        </p:txBody>
-      </p:sp>
-      <p:sp>
-        <p:nvSpPr>
-          <p:cNvPr id="17" name="TextBox 16"/>
-          <p:cNvSpPr txBox="1"/>
-          <p:nvPr/>
-        </p:nvSpPr>
-        <p:spPr>
-          <a:xfrm>
-            <a:off x="6080760" y="3054096"/>
-            <a:ext cx="5242255" cy="457200"/>
-          </a:xfrm>
-          <a:prstGeom prst="rect">
-            <a:avLst/>
-          </a:prstGeom>
-          <a:noFill/>
-        </p:spPr>
-        <p:txBody>
-          <a:bodyPr wrap="square" anchor="t" lIns="0" rIns="0" tIns="0" bIns="0">
-            <a:spAutoFit/>
-          </a:bodyPr>
-          <a:lstStyle/>
-          <a:p>
-            <a:pPr algn="l">
-              <a:lnSpc>
-                <a:spcPct val="140000"/>
-              </a:lnSpc>
-              <a:spcBef>
-                <a:spcPts val="0"/>
-              </a:spcBef>
-              <a:spcAft>
-                <a:spcPts val="0"/>
-              </a:spcAft>
-            </a:pPr>
-            <a:r>
-              <a:rPr sz="1200" b="0" i="0">
-                <a:solidFill>
-                  <a:srgbClr val="5B6B7E"/>
-                </a:solidFill>
-                <a:latin typeface="Inter"/>
-              </a:rPr>
-              <a:t>8 tests unitaires, pas un filet de sécurité</a:t>
-            </a:r>
-          </a:p>
-        </p:txBody>
-      </p:sp>
-      <p:sp>
-        <p:nvSpPr>
-          <p:cNvPr id="18" name="TextBox 17"/>
-          <p:cNvSpPr txBox="1"/>
-          <p:nvPr/>
-        </p:nvSpPr>
-        <p:spPr>
-          <a:xfrm>
-            <a:off x="6080760" y="3547872"/>
-            <a:ext cx="5242255" cy="256032"/>
-          </a:xfrm>
-          <a:prstGeom prst="rect">
-            <a:avLst/>
-          </a:prstGeom>
-          <a:noFill/>
-        </p:spPr>
-        <p:txBody>
-          <a:bodyPr wrap="square" anchor="t" lIns="0" rIns="0" tIns="0" bIns="0">
-            <a:spAutoFit/>
-          </a:bodyPr>
-          <a:lstStyle/>
-          <a:p>
-            <a:pPr algn="l">
-              <a:lnSpc>
-                <a:spcPct val="125000"/>
-              </a:lnSpc>
-              <a:spcBef>
-                <a:spcPts val="0"/>
-              </a:spcBef>
-              <a:spcAft>
-                <a:spcPts val="0"/>
-              </a:spcAft>
-            </a:pPr>
-            <a:r>
-              <a:rPr sz="1300" b="1" i="0">
-                <a:solidFill>
-                  <a:srgbClr val="E0623C"/>
-                </a:solidFill>
-                <a:latin typeface="Inter"/>
-              </a:rPr>
-              <a:t>iOS compilé, peu éprouvé</a:t>
-            </a:r>
-          </a:p>
-        </p:txBody>
-      </p:sp>
-      <p:sp>
-        <p:nvSpPr>
-          <p:cNvPr id="19" name="TextBox 18"/>
-          <p:cNvSpPr txBox="1"/>
-          <p:nvPr/>
-        </p:nvSpPr>
-        <p:spPr>
-          <a:xfrm>
-            <a:off x="6080760" y="3822192"/>
-            <a:ext cx="5242255" cy="457200"/>
-          </a:xfrm>
-          <a:prstGeom prst="rect">
-            <a:avLst/>
-          </a:prstGeom>
-          <a:noFill/>
-        </p:spPr>
-        <p:txBody>
-          <a:bodyPr wrap="square" anchor="t" lIns="0" rIns="0" tIns="0" bIns="0">
-            <a:spAutoFit/>
-          </a:bodyPr>
-          <a:lstStyle/>
-          <a:p>
-            <a:pPr algn="l">
-              <a:lnSpc>
-                <a:spcPct val="140000"/>
-              </a:lnSpc>
-              <a:spcBef>
-                <a:spcPts val="0"/>
-              </a:spcBef>
-              <a:spcAft>
-                <a:spcPts val="0"/>
-              </a:spcAft>
-            </a:pPr>
-            <a:r>
-              <a:rPr sz="1200" b="0" i="0">
-                <a:solidFill>
-                  <a:srgbClr val="5B6B7E"/>
-                </a:solidFill>
-                <a:latin typeface="Inter"/>
-              </a:rPr>
-              <a:t>construit à chaque changement, peu utilisé sur un appareil réel</a:t>
-            </a:r>
-          </a:p>
-        </p:txBody>
-      </p:sp>
-      <p:sp>
-        <p:nvSpPr>
-          <p:cNvPr id="20" name="Rounded Rectangle 19"/>
-          <p:cNvSpPr/>
-          <p:nvPr/>
-        </p:nvSpPr>
-        <p:spPr>
-          <a:xfrm>
-            <a:off x="868680" y="5440680"/>
-            <a:ext cx="10454335" cy="731520"/>
-          </a:xfrm>
-          <a:prstGeom prst="roundRect">
-            <a:avLst>
-              <a:gd name="adj" fmla="val 5000"/>
-            </a:avLst>
-          </a:prstGeom>
-          <a:solidFill>
-            <a:srgbClr val="0B2545"/>
-          </a:solidFill>
-          <a:ln>
-            <a:noFill/>
-          </a:ln>
-          <a:effectLst/>
-        </p:spPr>
-        <p:style>
-          <a:lnRef idx="1">
-            <a:schemeClr val="accent1"/>
-          </a:lnRef>
-          <a:fillRef idx="3">
-            <a:schemeClr val="accent1"/>
-          </a:fillRef>
-          <a:effectRef idx="2">
-            <a:schemeClr val="accent1"/>
-          </a:effectRef>
-          <a:fontRef idx="minor">
-            <a:schemeClr val="lt1"/>
-          </a:fontRef>
-        </p:style>
-        <p:txBody>
-          <a:bodyPr rtlCol="0" anchor="ctr" wrap="square"/>
-          <a:lstStyle/>
-          <a:p>
-            <a:pPr algn="ctr"/>
-          </a:p>
-        </p:txBody>
-      </p:sp>
-      <p:sp>
-        <p:nvSpPr>
-          <p:cNvPr id="21" name="TextBox 20"/>
-          <p:cNvSpPr txBox="1"/>
-          <p:nvPr/>
-        </p:nvSpPr>
-        <p:spPr>
-          <a:xfrm>
-            <a:off x="868680" y="5577840"/>
-            <a:ext cx="2090867" cy="310896"/>
-          </a:xfrm>
-          <a:prstGeom prst="rect">
-            <a:avLst/>
-          </a:prstGeom>
-          <a:noFill/>
-        </p:spPr>
-        <p:txBody>
-          <a:bodyPr wrap="square" anchor="t" lIns="0" rIns="0" tIns="0" bIns="0">
-            <a:spAutoFit/>
-          </a:bodyPr>
-          <a:lstStyle/>
-          <a:p>
-            <a:pPr algn="ctr">
-              <a:lnSpc>
-                <a:spcPct val="125000"/>
-              </a:lnSpc>
-              <a:spcBef>
-                <a:spcPts val="0"/>
-              </a:spcBef>
-              <a:spcAft>
-                <a:spcPts val="0"/>
-              </a:spcAft>
-            </a:pPr>
-            <a:r>
-              <a:rPr sz="2100" b="1" i="0">
-                <a:solidFill>
-                  <a:srgbClr val="FFFFFF"/>
-                </a:solidFill>
-                <a:latin typeface="Fraunces"/>
-              </a:rPr>
-              <a:t>242</a:t>
-            </a:r>
-          </a:p>
-        </p:txBody>
-      </p:sp>
-      <p:sp>
-        <p:nvSpPr>
-          <p:cNvPr id="22" name="TextBox 21"/>
-          <p:cNvSpPr txBox="1"/>
-          <p:nvPr/>
-        </p:nvSpPr>
-        <p:spPr>
-          <a:xfrm>
-            <a:off x="868680" y="5907024"/>
-            <a:ext cx="2090867" cy="237744"/>
-          </a:xfrm>
-          <a:prstGeom prst="rect">
-            <a:avLst/>
-          </a:prstGeom>
-          <a:noFill/>
-        </p:spPr>
-        <p:txBody>
-          <a:bodyPr wrap="square" anchor="t" lIns="0" rIns="0" tIns="0" bIns="0">
-            <a:spAutoFit/>
-          </a:bodyPr>
-          <a:lstStyle/>
-          <a:p>
-            <a:pPr algn="ctr">
-              <a:lnSpc>
-                <a:spcPct val="125000"/>
-              </a:lnSpc>
-              <a:spcBef>
-                <a:spcPts val="0"/>
-              </a:spcBef>
-              <a:spcAft>
-                <a:spcPts val="0"/>
-              </a:spcAft>
-            </a:pPr>
-            <a:r>
-              <a:rPr sz="1000" b="0" i="0">
-                <a:solidFill>
-                  <a:srgbClr val="8DA0B5"/>
-                </a:solidFill>
-                <a:latin typeface="Inter"/>
-              </a:rPr>
-              <a:t>commits</a:t>
-            </a:r>
-          </a:p>
-        </p:txBody>
-      </p:sp>
-      <p:sp>
-        <p:nvSpPr>
-          <p:cNvPr id="23" name="TextBox 22"/>
-          <p:cNvSpPr txBox="1"/>
-          <p:nvPr/>
-        </p:nvSpPr>
-        <p:spPr>
-          <a:xfrm>
-            <a:off x="2959547" y="5577840"/>
-            <a:ext cx="2090867" cy="310896"/>
-          </a:xfrm>
-          <a:prstGeom prst="rect">
-            <a:avLst/>
-          </a:prstGeom>
-          <a:noFill/>
-        </p:spPr>
-        <p:txBody>
-          <a:bodyPr wrap="square" anchor="t" lIns="0" rIns="0" tIns="0" bIns="0">
-            <a:spAutoFit/>
-          </a:bodyPr>
-          <a:lstStyle/>
-          <a:p>
-            <a:pPr algn="ctr">
-              <a:lnSpc>
-                <a:spcPct val="125000"/>
-              </a:lnSpc>
-              <a:spcBef>
-                <a:spcPts val="0"/>
-              </a:spcBef>
-              <a:spcAft>
-                <a:spcPts val="0"/>
-              </a:spcAft>
-            </a:pPr>
-            <a:r>
-              <a:rPr sz="2100" b="1" i="0">
-                <a:solidFill>
-                  <a:srgbClr val="FFFFFF"/>
-                </a:solidFill>
-                <a:latin typeface="Fraunces"/>
-              </a:rPr>
-              <a:t>52</a:t>
-            </a:r>
-          </a:p>
-        </p:txBody>
-      </p:sp>
-      <p:sp>
-        <p:nvSpPr>
-          <p:cNvPr id="24" name="TextBox 23"/>
-          <p:cNvSpPr txBox="1"/>
-          <p:nvPr/>
-        </p:nvSpPr>
-        <p:spPr>
-          <a:xfrm>
-            <a:off x="2959547" y="5907024"/>
-            <a:ext cx="2090867" cy="237744"/>
-          </a:xfrm>
-          <a:prstGeom prst="rect">
-            <a:avLst/>
-          </a:prstGeom>
-          <a:noFill/>
-        </p:spPr>
-        <p:txBody>
-          <a:bodyPr wrap="square" anchor="t" lIns="0" rIns="0" tIns="0" bIns="0">
-            <a:spAutoFit/>
-          </a:bodyPr>
-          <a:lstStyle/>
-          <a:p>
-            <a:pPr algn="ctr">
-              <a:lnSpc>
-                <a:spcPct val="125000"/>
-              </a:lnSpc>
-              <a:spcBef>
-                <a:spcPts val="0"/>
-              </a:spcBef>
-              <a:spcAft>
-                <a:spcPts val="0"/>
-              </a:spcAft>
-            </a:pPr>
-            <a:r>
-              <a:rPr sz="1000" b="0" i="0">
-                <a:solidFill>
-                  <a:srgbClr val="8DA0B5"/>
-                </a:solidFill>
-                <a:latin typeface="Inter"/>
-              </a:rPr>
-              <a:t>pull requests</a:t>
-            </a:r>
-          </a:p>
-        </p:txBody>
-      </p:sp>
-      <p:sp>
-        <p:nvSpPr>
-          <p:cNvPr id="25" name="TextBox 24"/>
-          <p:cNvSpPr txBox="1"/>
-          <p:nvPr/>
-        </p:nvSpPr>
-        <p:spPr>
-          <a:xfrm>
-            <a:off x="5050414" y="5577840"/>
-            <a:ext cx="2090867" cy="310896"/>
-          </a:xfrm>
-          <a:prstGeom prst="rect">
-            <a:avLst/>
-          </a:prstGeom>
-          <a:noFill/>
-        </p:spPr>
-        <p:txBody>
-          <a:bodyPr wrap="square" anchor="t" lIns="0" rIns="0" tIns="0" bIns="0">
-            <a:spAutoFit/>
-          </a:bodyPr>
-          <a:lstStyle/>
-          <a:p>
-            <a:pPr algn="ctr">
-              <a:lnSpc>
-                <a:spcPct val="125000"/>
-              </a:lnSpc>
-              <a:spcBef>
-                <a:spcPts val="0"/>
-              </a:spcBef>
-              <a:spcAft>
-                <a:spcPts val="0"/>
-              </a:spcAft>
-            </a:pPr>
-            <a:r>
-              <a:rPr sz="2100" b="1" i="0">
-                <a:solidFill>
-                  <a:srgbClr val="FFFFFF"/>
-                </a:solidFill>
-                <a:latin typeface="Fraunces"/>
-              </a:rPr>
-              <a:t>35</a:t>
-            </a:r>
-          </a:p>
-        </p:txBody>
-      </p:sp>
-      <p:sp>
-        <p:nvSpPr>
-          <p:cNvPr id="26" name="TextBox 25"/>
-          <p:cNvSpPr txBox="1"/>
-          <p:nvPr/>
-        </p:nvSpPr>
-        <p:spPr>
-          <a:xfrm>
-            <a:off x="5050414" y="5907024"/>
-            <a:ext cx="2090867" cy="237744"/>
-          </a:xfrm>
-          <a:prstGeom prst="rect">
-            <a:avLst/>
-          </a:prstGeom>
-          <a:noFill/>
-        </p:spPr>
-        <p:txBody>
-          <a:bodyPr wrap="square" anchor="t" lIns="0" rIns="0" tIns="0" bIns="0">
-            <a:spAutoFit/>
-          </a:bodyPr>
-          <a:lstStyle/>
-          <a:p>
-            <a:pPr algn="ctr">
-              <a:lnSpc>
-                <a:spcPct val="125000"/>
-              </a:lnSpc>
-              <a:spcBef>
-                <a:spcPts val="0"/>
-              </a:spcBef>
-              <a:spcAft>
-                <a:spcPts val="0"/>
-              </a:spcAft>
-            </a:pPr>
-            <a:r>
-              <a:rPr sz="1000" b="0" i="0">
-                <a:solidFill>
-                  <a:srgbClr val="8DA0B5"/>
-                </a:solidFill>
-                <a:latin typeface="Inter"/>
-              </a:rPr>
-              <a:t>releases</a:t>
-            </a:r>
-          </a:p>
-        </p:txBody>
-      </p:sp>
-      <p:sp>
-        <p:nvSpPr>
-          <p:cNvPr id="27" name="TextBox 26"/>
-          <p:cNvSpPr txBox="1"/>
-          <p:nvPr/>
-        </p:nvSpPr>
-        <p:spPr>
-          <a:xfrm>
-            <a:off x="7141281" y="5577840"/>
-            <a:ext cx="2090867" cy="310896"/>
-          </a:xfrm>
-          <a:prstGeom prst="rect">
-            <a:avLst/>
-          </a:prstGeom>
-          <a:noFill/>
-        </p:spPr>
-        <p:txBody>
-          <a:bodyPr wrap="square" anchor="t" lIns="0" rIns="0" tIns="0" bIns="0">
-            <a:spAutoFit/>
-          </a:bodyPr>
-          <a:lstStyle/>
-          <a:p>
-            <a:pPr algn="ctr">
-              <a:lnSpc>
-                <a:spcPct val="125000"/>
-              </a:lnSpc>
-              <a:spcBef>
-                <a:spcPts val="0"/>
-              </a:spcBef>
-              <a:spcAft>
-                <a:spcPts val="0"/>
-              </a:spcAft>
-            </a:pPr>
-            <a:r>
-              <a:rPr sz="2100" b="1" i="0">
-                <a:solidFill>
-                  <a:srgbClr val="FFFFFF"/>
-                </a:solidFill>
-                <a:latin typeface="Fraunces"/>
-              </a:rPr>
-              <a:t>19</a:t>
-            </a:r>
-          </a:p>
-        </p:txBody>
-      </p:sp>
-      <p:sp>
-        <p:nvSpPr>
-          <p:cNvPr id="28" name="TextBox 27"/>
-          <p:cNvSpPr txBox="1"/>
-          <p:nvPr/>
-        </p:nvSpPr>
-        <p:spPr>
-          <a:xfrm>
-            <a:off x="7141281" y="5907024"/>
-            <a:ext cx="2090867" cy="237744"/>
-          </a:xfrm>
-          <a:prstGeom prst="rect">
-            <a:avLst/>
-          </a:prstGeom>
-          <a:noFill/>
-        </p:spPr>
-        <p:txBody>
-          <a:bodyPr wrap="square" anchor="t" lIns="0" rIns="0" tIns="0" bIns="0">
-            <a:spAutoFit/>
-          </a:bodyPr>
-          <a:lstStyle/>
-          <a:p>
-            <a:pPr algn="ctr">
-              <a:lnSpc>
-                <a:spcPct val="125000"/>
-              </a:lnSpc>
-              <a:spcBef>
-                <a:spcPts val="0"/>
-              </a:spcBef>
-              <a:spcAft>
-                <a:spcPts val="0"/>
-              </a:spcAft>
-            </a:pPr>
-            <a:r>
-              <a:rPr sz="1000" b="0" i="0">
-                <a:solidFill>
-                  <a:srgbClr val="8DA0B5"/>
-                </a:solidFill>
-                <a:latin typeface="Inter"/>
-              </a:rPr>
-              <a:t>migrations</a:t>
-            </a:r>
-          </a:p>
-        </p:txBody>
-      </p:sp>
-      <p:sp>
-        <p:nvSpPr>
-          <p:cNvPr id="29" name="TextBox 28"/>
-          <p:cNvSpPr txBox="1"/>
-          <p:nvPr/>
-        </p:nvSpPr>
-        <p:spPr>
-          <a:xfrm>
-            <a:off x="9232148" y="5577840"/>
-            <a:ext cx="2090867" cy="310896"/>
-          </a:xfrm>
-          <a:prstGeom prst="rect">
-            <a:avLst/>
-          </a:prstGeom>
-          <a:noFill/>
-        </p:spPr>
-        <p:txBody>
-          <a:bodyPr wrap="square" anchor="t" lIns="0" rIns="0" tIns="0" bIns="0">
-            <a:spAutoFit/>
-          </a:bodyPr>
-          <a:lstStyle/>
-          <a:p>
-            <a:pPr algn="ctr">
-              <a:lnSpc>
-                <a:spcPct val="125000"/>
-              </a:lnSpc>
-              <a:spcBef>
-                <a:spcPts val="0"/>
-              </a:spcBef>
-              <a:spcAft>
-                <a:spcPts val="0"/>
-              </a:spcAft>
-            </a:pPr>
-            <a:r>
-              <a:rPr sz="2100" b="1" i="0">
-                <a:solidFill>
-                  <a:srgbClr val="FFFFFF"/>
-                </a:solidFill>
-                <a:latin typeface="Fraunces"/>
-              </a:rPr>
-              <a:t>6 044</a:t>
-            </a:r>
-          </a:p>
-        </p:txBody>
-      </p:sp>
-      <p:sp>
-        <p:nvSpPr>
-          <p:cNvPr id="30" name="TextBox 29"/>
-          <p:cNvSpPr txBox="1"/>
-          <p:nvPr/>
-        </p:nvSpPr>
-        <p:spPr>
-          <a:xfrm>
-            <a:off x="9232148" y="5907024"/>
-            <a:ext cx="2090867" cy="237744"/>
-          </a:xfrm>
-          <a:prstGeom prst="rect">
-            <a:avLst/>
-          </a:prstGeom>
-          <a:noFill/>
-        </p:spPr>
-        <p:txBody>
-          <a:bodyPr wrap="square" anchor="t" lIns="0" rIns="0" tIns="0" bIns="0">
-            <a:spAutoFit/>
-          </a:bodyPr>
-          <a:lstStyle/>
-          <a:p>
-            <a:pPr algn="ctr">
-              <a:lnSpc>
-                <a:spcPct val="125000"/>
-              </a:lnSpc>
-              <a:spcBef>
-                <a:spcPts val="0"/>
-              </a:spcBef>
-              <a:spcAft>
-                <a:spcPts val="0"/>
-              </a:spcAft>
-            </a:pPr>
-            <a:r>
-              <a:rPr sz="1000" b="0" i="0">
-                <a:solidFill>
-                  <a:srgbClr val="8DA0B5"/>
-                </a:solidFill>
-                <a:latin typeface="Inter"/>
-              </a:rPr>
-              <a:t>lignes de Kotlin</a:t>
-            </a:r>
-          </a:p>
-        </p:txBody>
-      </p:sp>
-      <p:sp>
-        <p:nvSpPr>
-          <p:cNvPr id="31" name="TextBox 30"/>
           <p:cNvSpPr txBox="1"/>
           <p:nvPr/>
         </p:nvSpPr>
@@ -14977,7 +13993,7 @@
             <a:r>
               <a:rPr sz="950" b="0" i="0">
                 <a:solidFill>
-                  <a:srgbClr val="5B6B7E"/>
+                  <a:srgbClr val="8DA0B5"/>
                 </a:solidFill>
                 <a:latin typeface="Inter"/>
               </a:rPr>

</xml_diff>